<commit_message>
docs: Rework C-Day poster for print-friendly output
Switch from dark theme to white/light-gray background to reduce
toner usage on large-format laser printer. Keep KSU black header
and gold footer from template as branding accents. Section headers
use compact black bars with gold accent stripes. Verified 48x36
inch dimensions match template exactly.
</commit_message>
<xml_diff>
--- a/docs/presentation/GexVisor_CDay_Poster.pptx
+++ b/docs/presentation/GexVisor_CDay_Poster.pptx
@@ -1917,14 +1917,14 @@
         </p:nvSpPr>
         <p:spPr>
           <a:xfrm>
-            <a:off x="13487400" y="2743200"/>
-            <a:ext cx="30403800" cy="27432000"/>
+            <a:off x="0" y="2743200"/>
+            <a:ext cx="43891200" cy="27432000"/>
           </a:xfrm>
           <a:prstGeom prst="rect">
             <a:avLst/>
           </a:prstGeom>
           <a:solidFill>
-            <a:srgbClr val="2B2B2B"/>
+            <a:srgbClr val="FFFFFF"/>
           </a:solidFill>
           <a:ln>
             <a:noFill/>
@@ -1955,34 +1955,45 @@
       </p:sp>
       <p:sp>
         <p:nvSpPr>
-          <p:cNvPr id="50" name="TextBox 49"/>
-          <p:cNvSpPr txBox="1"/>
-          <p:nvPr/>
-        </p:nvSpPr>
-        <p:spPr>
-          <a:xfrm>
-            <a:off x="1371600" y="3200400"/>
-            <a:ext cx="10972800" cy="1828800"/>
-          </a:xfrm>
-          <a:prstGeom prst="rect">
-            <a:avLst/>
-          </a:prstGeom>
-          <a:noFill/>
-        </p:spPr>
-        <p:txBody>
-          <a:bodyPr wrap="square"/>
-          <a:lstStyle/>
-          <a:p>
-            <a:pPr algn="l"/>
-            <a:r>
-              <a:rPr sz="4400" b="1">
-                <a:solidFill>
-                  <a:srgbClr val="FFC000"/>
-                </a:solidFill>
-                <a:latin typeface="Arial"/>
-              </a:rPr>
-              <a:t>Architecture, WebAssembly, and Test Infrastructure for a .NET Financial Visualization Platform</a:t>
-            </a:r>
+          <p:cNvPr id="50" name="Rectangle 49"/>
+          <p:cNvSpPr/>
+          <p:nvPr/>
+        </p:nvSpPr>
+        <p:spPr>
+          <a:xfrm>
+            <a:off x="13487400" y="2743200"/>
+            <a:ext cx="30403800" cy="27432000"/>
+          </a:xfrm>
+          <a:prstGeom prst="rect">
+            <a:avLst/>
+          </a:prstGeom>
+          <a:solidFill>
+            <a:srgbClr val="F7F7F7"/>
+          </a:solidFill>
+          <a:ln>
+            <a:noFill/>
+          </a:ln>
+          <a:effectLst/>
+        </p:spPr>
+        <p:style>
+          <a:lnRef idx="1">
+            <a:schemeClr val="accent1"/>
+          </a:lnRef>
+          <a:fillRef idx="3">
+            <a:schemeClr val="accent1"/>
+          </a:fillRef>
+          <a:effectRef idx="2">
+            <a:schemeClr val="accent1"/>
+          </a:effectRef>
+          <a:fontRef idx="minor">
+            <a:schemeClr val="lt1"/>
+          </a:fontRef>
+        </p:style>
+        <p:txBody>
+          <a:bodyPr rtlCol="0" anchor="ctr"/>
+          <a:lstStyle/>
+          <a:p>
+            <a:pPr algn="ctr"/>
           </a:p>
         </p:txBody>
       </p:sp>
@@ -1994,8 +2005,8 @@
         </p:nvSpPr>
         <p:spPr>
           <a:xfrm>
-            <a:off x="1371600" y="5486400"/>
-            <a:ext cx="182880" cy="640080"/>
+            <a:off x="13258800" y="3200400"/>
+            <a:ext cx="73152" cy="26517600"/>
           </a:xfrm>
           <a:prstGeom prst="rect">
             <a:avLst/>
@@ -2038,8 +2049,8 @@
         </p:nvSpPr>
         <p:spPr>
           <a:xfrm>
-            <a:off x="1737360" y="5468112"/>
-            <a:ext cx="10607040" cy="640080"/>
+            <a:off x="1371600" y="3200400"/>
+            <a:ext cx="10972800" cy="1828800"/>
           </a:xfrm>
           <a:prstGeom prst="rect">
             <a:avLst/>
@@ -2052,101 +2063,58 @@
           <a:p>
             <a:pPr algn="l"/>
             <a:r>
-              <a:rPr sz="4800" b="1">
-                <a:solidFill>
-                  <a:srgbClr val="FFFFFF"/>
+              <a:rPr sz="4400" b="1">
+                <a:solidFill>
+                  <a:srgbClr val="C48E00"/>
                 </a:solidFill>
                 <a:latin typeface="Arial"/>
               </a:rPr>
-              <a:t>The Problem</a:t>
-            </a:r>
-          </a:p>
-        </p:txBody>
-      </p:sp>
-      <p:sp>
-        <p:nvSpPr>
-          <p:cNvPr id="53" name="TextBox 52"/>
-          <p:cNvSpPr txBox="1"/>
-          <p:nvPr/>
-        </p:nvSpPr>
-        <p:spPr>
-          <a:xfrm>
-            <a:off x="1554480" y="6263640"/>
-            <a:ext cx="10607040" cy="2286000"/>
-          </a:xfrm>
-          <a:prstGeom prst="rect">
-            <a:avLst/>
-          </a:prstGeom>
-          <a:noFill/>
-        </p:spPr>
-        <p:txBody>
-          <a:bodyPr wrap="square">
-            <a:spAutoFit/>
-          </a:bodyPr>
-          <a:lstStyle/>
-          <a:p>
-            <a:pPr>
-              <a:spcAft>
-                <a:spcPts val="600"/>
-              </a:spcAft>
-            </a:pPr>
-            <a:r>
-              <a:rPr sz="3400">
-                <a:solidFill>
-                  <a:srgbClr val="FFFFFF"/>
-                </a:solidFill>
-                <a:latin typeface="Arial"/>
-              </a:rPr>
-              <a:t>• Existing GEX tools: fragmented JS scripts, no tests, no CI</a:t>
-            </a:r>
-          </a:p>
-          <a:p>
-            <a:pPr>
-              <a:spcAft>
-                <a:spcPts val="600"/>
-              </a:spcAft>
-            </a:pPr>
-            <a:r>
-              <a:rPr sz="3400">
-                <a:solidFill>
-                  <a:srgbClr val="FFFFFF"/>
-                </a:solidFill>
-                <a:latin typeface="Arial"/>
-              </a:rPr>
-              <a:t>• Options visualization needs real-time + historical views</a:t>
-            </a:r>
-          </a:p>
-          <a:p>
-            <a:pPr>
-              <a:spcAft>
-                <a:spcPts val="600"/>
-              </a:spcAft>
-            </a:pPr>
-            <a:r>
-              <a:rPr sz="3400">
-                <a:solidFill>
-                  <a:srgbClr val="FFFFFF"/>
-                </a:solidFill>
-                <a:latin typeface="Arial"/>
-              </a:rPr>
-              <a:t>• Research workflows disconnected from analysis tooling</a:t>
-            </a:r>
-          </a:p>
-          <a:p>
-            <a:pPr>
-              <a:spcAft>
-                <a:spcPts val="600"/>
-              </a:spcAft>
-            </a:pPr>
-            <a:r>
-              <a:rPr sz="3400">
-                <a:solidFill>
-                  <a:srgbClr val="FFFFFF"/>
-                </a:solidFill>
-                <a:latin typeface="Arial"/>
-              </a:rPr>
-              <a:t>• No cross-platform solution (browser-based needed)</a:t>
-            </a:r>
+              <a:t>Architecture, WebAssembly, and Test Infrastructure for a .NET Financial Visualization Platform</a:t>
+            </a:r>
+          </a:p>
+        </p:txBody>
+      </p:sp>
+      <p:sp>
+        <p:nvSpPr>
+          <p:cNvPr id="53" name="Rectangle 52"/>
+          <p:cNvSpPr/>
+          <p:nvPr/>
+        </p:nvSpPr>
+        <p:spPr>
+          <a:xfrm>
+            <a:off x="1371600" y="5486400"/>
+            <a:ext cx="10972800" cy="685800"/>
+          </a:xfrm>
+          <a:prstGeom prst="rect">
+            <a:avLst/>
+          </a:prstGeom>
+          <a:solidFill>
+            <a:srgbClr val="1A1A1A"/>
+          </a:solidFill>
+          <a:ln>
+            <a:noFill/>
+          </a:ln>
+          <a:effectLst/>
+        </p:spPr>
+        <p:style>
+          <a:lnRef idx="1">
+            <a:schemeClr val="accent1"/>
+          </a:lnRef>
+          <a:fillRef idx="3">
+            <a:schemeClr val="accent1"/>
+          </a:fillRef>
+          <a:effectRef idx="2">
+            <a:schemeClr val="accent1"/>
+          </a:effectRef>
+          <a:fontRef idx="minor">
+            <a:schemeClr val="lt1"/>
+          </a:fontRef>
+        </p:style>
+        <p:txBody>
+          <a:bodyPr rtlCol="0" anchor="ctr"/>
+          <a:lstStyle/>
+          <a:p>
+            <a:pPr algn="ctr"/>
           </a:p>
         </p:txBody>
       </p:sp>
@@ -2158,8 +2126,8 @@
         </p:nvSpPr>
         <p:spPr>
           <a:xfrm>
-            <a:off x="1371600" y="9189720"/>
-            <a:ext cx="182880" cy="640080"/>
+            <a:off x="1371600" y="5486400"/>
+            <a:ext cx="182880" cy="685800"/>
           </a:xfrm>
           <a:prstGeom prst="rect">
             <a:avLst/>
@@ -2202,8 +2170,8 @@
         </p:nvSpPr>
         <p:spPr>
           <a:xfrm>
-            <a:off x="1737360" y="9171432"/>
-            <a:ext cx="10607040" cy="640080"/>
+            <a:off x="1737360" y="5532120"/>
+            <a:ext cx="10515600" cy="594360"/>
           </a:xfrm>
           <a:prstGeom prst="rect">
             <a:avLst/>
@@ -2216,39 +2184,123 @@
           <a:p>
             <a:pPr algn="l"/>
             <a:r>
-              <a:rPr sz="4800" b="1">
+              <a:rPr sz="4400" b="1">
                 <a:solidFill>
                   <a:srgbClr val="FFFFFF"/>
                 </a:solidFill>
                 <a:latin typeface="Arial"/>
               </a:rPr>
-              <a:t>System Architecture</a:t>
-            </a:r>
-          </a:p>
-        </p:txBody>
-      </p:sp>
-      <p:sp>
-        <p:nvSpPr>
-          <p:cNvPr id="56" name="Rounded Rectangle 55"/>
+              <a:t>The Problem</a:t>
+            </a:r>
+          </a:p>
+        </p:txBody>
+      </p:sp>
+      <p:sp>
+        <p:nvSpPr>
+          <p:cNvPr id="56" name="TextBox 55"/>
+          <p:cNvSpPr txBox="1"/>
+          <p:nvPr/>
+        </p:nvSpPr>
+        <p:spPr>
+          <a:xfrm>
+            <a:off x="1554480" y="6309360"/>
+            <a:ext cx="10607040" cy="2286000"/>
+          </a:xfrm>
+          <a:prstGeom prst="rect">
+            <a:avLst/>
+          </a:prstGeom>
+          <a:noFill/>
+        </p:spPr>
+        <p:txBody>
+          <a:bodyPr wrap="square">
+            <a:spAutoFit/>
+          </a:bodyPr>
+          <a:lstStyle/>
+          <a:p>
+            <a:pPr>
+              <a:spcAft>
+                <a:spcPts val="600"/>
+              </a:spcAft>
+            </a:pPr>
+            <a:r>
+              <a:rPr sz="3400">
+                <a:solidFill>
+                  <a:srgbClr val="2D2D2D"/>
+                </a:solidFill>
+                <a:latin typeface="Arial"/>
+              </a:rPr>
+              <a:t>• Existing GEX tools: fragmented JS scripts, no tests, no CI</a:t>
+            </a:r>
+          </a:p>
+          <a:p>
+            <a:pPr>
+              <a:spcAft>
+                <a:spcPts val="600"/>
+              </a:spcAft>
+            </a:pPr>
+            <a:r>
+              <a:rPr sz="3400">
+                <a:solidFill>
+                  <a:srgbClr val="2D2D2D"/>
+                </a:solidFill>
+                <a:latin typeface="Arial"/>
+              </a:rPr>
+              <a:t>• Options visualization needs real-time + historical views</a:t>
+            </a:r>
+          </a:p>
+          <a:p>
+            <a:pPr>
+              <a:spcAft>
+                <a:spcPts val="600"/>
+              </a:spcAft>
+            </a:pPr>
+            <a:r>
+              <a:rPr sz="3400">
+                <a:solidFill>
+                  <a:srgbClr val="2D2D2D"/>
+                </a:solidFill>
+                <a:latin typeface="Arial"/>
+              </a:rPr>
+              <a:t>• Research workflows disconnected from analysis tooling</a:t>
+            </a:r>
+          </a:p>
+          <a:p>
+            <a:pPr>
+              <a:spcAft>
+                <a:spcPts val="600"/>
+              </a:spcAft>
+            </a:pPr>
+            <a:r>
+              <a:rPr sz="3400">
+                <a:solidFill>
+                  <a:srgbClr val="2D2D2D"/>
+                </a:solidFill>
+                <a:latin typeface="Arial"/>
+              </a:rPr>
+              <a:t>• No cross-platform solution (browser-based needed)</a:t>
+            </a:r>
+          </a:p>
+        </p:txBody>
+      </p:sp>
+      <p:sp>
+        <p:nvSpPr>
+          <p:cNvPr id="57" name="Rectangle 56"/>
           <p:cNvSpPr/>
           <p:nvPr/>
         </p:nvSpPr>
         <p:spPr>
           <a:xfrm>
-            <a:off x="1371600" y="9966960"/>
-            <a:ext cx="10972800" cy="5486400"/>
-          </a:xfrm>
-          <a:prstGeom prst="roundRect">
+            <a:off x="1371600" y="9235440"/>
+            <a:ext cx="10972800" cy="685800"/>
+          </a:xfrm>
+          <a:prstGeom prst="rect">
             <a:avLst/>
           </a:prstGeom>
           <a:solidFill>
-            <a:srgbClr val="E8E8E8"/>
+            <a:srgbClr val="1A1A1A"/>
           </a:solidFill>
-          <a:ln w="25400">
-            <a:solidFill>
-              <a:srgbClr val="666666"/>
-            </a:solidFill>
-            <a:prstDash val="dash"/>
+          <a:ln>
+            <a:noFill/>
           </a:ln>
           <a:effectLst/>
         </p:spPr>
@@ -2276,80 +2328,14 @@
       </p:sp>
       <p:sp>
         <p:nvSpPr>
-          <p:cNvPr id="57" name="TextBox 56"/>
-          <p:cNvSpPr txBox="1"/>
-          <p:nvPr/>
-        </p:nvSpPr>
-        <p:spPr>
-          <a:xfrm>
-            <a:off x="1371600" y="12298680"/>
-            <a:ext cx="10972800" cy="548640"/>
-          </a:xfrm>
-          <a:prstGeom prst="rect">
-            <a:avLst/>
-          </a:prstGeom>
-          <a:noFill/>
-        </p:spPr>
-        <p:txBody>
-          <a:bodyPr wrap="square"/>
-          <a:lstStyle/>
-          <a:p>
-            <a:pPr algn="ctr"/>
-            <a:r>
-              <a:rPr sz="3600" b="1">
-                <a:solidFill>
-                  <a:srgbClr val="666666"/>
-                </a:solidFill>
-                <a:latin typeface="Arial"/>
-              </a:rPr>
-              <a:t>ARCHITECTURE DIAGRAM</a:t>
-            </a:r>
-          </a:p>
-        </p:txBody>
-      </p:sp>
-      <p:sp>
-        <p:nvSpPr>
-          <p:cNvPr id="58" name="TextBox 57"/>
-          <p:cNvSpPr txBox="1"/>
-          <p:nvPr/>
-        </p:nvSpPr>
-        <p:spPr>
-          <a:xfrm>
-            <a:off x="1371600" y="12893040"/>
-            <a:ext cx="10972800" cy="457200"/>
-          </a:xfrm>
-          <a:prstGeom prst="rect">
-            <a:avLst/>
-          </a:prstGeom>
-          <a:noFill/>
-        </p:spPr>
-        <p:txBody>
-          <a:bodyPr wrap="square"/>
-          <a:lstStyle/>
-          <a:p>
-            <a:pPr algn="ctr"/>
-            <a:r>
-              <a:rPr sz="2200" b="0">
-                <a:solidFill>
-                  <a:srgbClr val="666666"/>
-                </a:solidFill>
-                <a:latin typeface="Arial"/>
-              </a:rPr>
-              <a:t>3-tier: UI → Core → API</a:t>
-            </a:r>
-          </a:p>
-        </p:txBody>
-      </p:sp>
-      <p:sp>
-        <p:nvSpPr>
-          <p:cNvPr id="59" name="Rectangle 58"/>
+          <p:cNvPr id="58" name="Rectangle 57"/>
           <p:cNvSpPr/>
           <p:nvPr/>
         </p:nvSpPr>
         <p:spPr>
           <a:xfrm>
-            <a:off x="1371600" y="15727680"/>
-            <a:ext cx="182880" cy="640080"/>
+            <a:off x="1371600" y="9235440"/>
+            <a:ext cx="182880" cy="685800"/>
           </a:xfrm>
           <a:prstGeom prst="rect">
             <a:avLst/>
@@ -2386,14 +2372,14 @@
       </p:sp>
       <p:sp>
         <p:nvSpPr>
-          <p:cNvPr id="60" name="TextBox 59"/>
+          <p:cNvPr id="59" name="TextBox 58"/>
           <p:cNvSpPr txBox="1"/>
           <p:nvPr/>
         </p:nvSpPr>
         <p:spPr>
           <a:xfrm>
-            <a:off x="1737360" y="15709392"/>
-            <a:ext cx="10607040" cy="640080"/>
+            <a:off x="1737360" y="9281160"/>
+            <a:ext cx="10515600" cy="594360"/>
           </a:xfrm>
           <a:prstGeom prst="rect">
             <a:avLst/>
@@ -2406,14 +2392,61 @@
           <a:p>
             <a:pPr algn="l"/>
             <a:r>
-              <a:rPr sz="4800" b="1">
+              <a:rPr sz="4400" b="1">
                 <a:solidFill>
                   <a:srgbClr val="FFFFFF"/>
                 </a:solidFill>
                 <a:latin typeface="Arial"/>
               </a:rPr>
-              <a:t>Technology Stack</a:t>
-            </a:r>
+              <a:t>System Architecture</a:t>
+            </a:r>
+          </a:p>
+        </p:txBody>
+      </p:sp>
+      <p:sp>
+        <p:nvSpPr>
+          <p:cNvPr id="60" name="Rounded Rectangle 59"/>
+          <p:cNvSpPr/>
+          <p:nvPr/>
+        </p:nvSpPr>
+        <p:spPr>
+          <a:xfrm>
+            <a:off x="1371600" y="10058400"/>
+            <a:ext cx="10972800" cy="5486400"/>
+          </a:xfrm>
+          <a:prstGeom prst="roundRect">
+            <a:avLst/>
+          </a:prstGeom>
+          <a:solidFill>
+            <a:srgbClr val="ECECEC"/>
+          </a:solidFill>
+          <a:ln w="19050">
+            <a:solidFill>
+              <a:srgbClr val="AAAAAA"/>
+            </a:solidFill>
+            <a:prstDash val="dash"/>
+          </a:ln>
+          <a:effectLst/>
+        </p:spPr>
+        <p:style>
+          <a:lnRef idx="1">
+            <a:schemeClr val="accent1"/>
+          </a:lnRef>
+          <a:fillRef idx="3">
+            <a:schemeClr val="accent1"/>
+          </a:fillRef>
+          <a:effectRef idx="2">
+            <a:schemeClr val="accent1"/>
+          </a:effectRef>
+          <a:fontRef idx="minor">
+            <a:schemeClr val="lt1"/>
+          </a:fontRef>
+        </p:style>
+        <p:txBody>
+          <a:bodyPr rtlCol="0" anchor="ctr"/>
+          <a:lstStyle/>
+          <a:p>
+            <a:pPr algn="ctr"/>
           </a:p>
         </p:txBody>
       </p:sp>
@@ -2425,8 +2458,8 @@
         </p:nvSpPr>
         <p:spPr>
           <a:xfrm>
-            <a:off x="1554480" y="16504920"/>
-            <a:ext cx="10607040" cy="3383279"/>
+            <a:off x="1371600" y="12390120"/>
+            <a:ext cx="10972800" cy="548640"/>
           </a:xfrm>
           <a:prstGeom prst="rect">
             <a:avLst/>
@@ -2434,118 +2467,109 @@
           <a:noFill/>
         </p:spPr>
         <p:txBody>
-          <a:bodyPr wrap="square">
-            <a:spAutoFit/>
-          </a:bodyPr>
-          <a:lstStyle/>
-          <a:p>
-            <a:pPr>
-              <a:spcAft>
-                <a:spcPts val="600"/>
-              </a:spcAft>
-            </a:pPr>
-            <a:r>
-              <a:rPr sz="3200">
-                <a:solidFill>
-                  <a:srgbClr val="FFFFFF"/>
+          <a:bodyPr wrap="square"/>
+          <a:lstStyle/>
+          <a:p>
+            <a:pPr algn="ctr"/>
+            <a:r>
+              <a:rPr sz="3600" b="1">
+                <a:solidFill>
+                  <a:srgbClr val="AAAAAA"/>
                 </a:solidFill>
                 <a:latin typeface="Arial"/>
               </a:rPr>
-              <a:t>• .NET 10 / Blazor WebAssembly (runs in browser via WASM)</a:t>
-            </a:r>
-          </a:p>
-          <a:p>
-            <a:pPr>
-              <a:spcAft>
-                <a:spcPts val="600"/>
-              </a:spcAft>
-            </a:pPr>
-            <a:r>
-              <a:rPr sz="3200">
-                <a:solidFill>
-                  <a:srgbClr val="FFFFFF"/>
+              <a:t>ARCHITECTURE DIAGRAM</a:t>
+            </a:r>
+          </a:p>
+        </p:txBody>
+      </p:sp>
+      <p:sp>
+        <p:nvSpPr>
+          <p:cNvPr id="62" name="TextBox 61"/>
+          <p:cNvSpPr txBox="1"/>
+          <p:nvPr/>
+        </p:nvSpPr>
+        <p:spPr>
+          <a:xfrm>
+            <a:off x="1371600" y="12984480"/>
+            <a:ext cx="10972800" cy="457200"/>
+          </a:xfrm>
+          <a:prstGeom prst="rect">
+            <a:avLst/>
+          </a:prstGeom>
+          <a:noFill/>
+        </p:spPr>
+        <p:txBody>
+          <a:bodyPr wrap="square"/>
+          <a:lstStyle/>
+          <a:p>
+            <a:pPr algn="ctr"/>
+            <a:r>
+              <a:rPr sz="2200" b="0">
+                <a:solidFill>
+                  <a:srgbClr val="AAAAAA"/>
                 </a:solidFill>
                 <a:latin typeface="Arial"/>
               </a:rPr>
-              <a:t>• C# throughout — replaced JS/Python prototype entirely</a:t>
-            </a:r>
-          </a:p>
-          <a:p>
-            <a:pPr>
-              <a:spcAft>
-                <a:spcPts val="600"/>
-              </a:spcAft>
-            </a:pPr>
-            <a:r>
-              <a:rPr sz="3200">
-                <a:solidFill>
-                  <a:srgbClr val="FFFFFF"/>
-                </a:solidFill>
-                <a:latin typeface="Arial"/>
-              </a:rPr>
-              <a:t>• ApexCharts for interactive financial visualizations</a:t>
-            </a:r>
-          </a:p>
-          <a:p>
-            <a:pPr>
-              <a:spcAft>
-                <a:spcPts val="600"/>
-              </a:spcAft>
-            </a:pPr>
-            <a:r>
-              <a:rPr sz="3200">
-                <a:solidFill>
-                  <a:srgbClr val="FFFFFF"/>
-                </a:solidFill>
-                <a:latin typeface="Arial"/>
-              </a:rPr>
-              <a:t>• SQLite caching layer for market data persistence</a:t>
-            </a:r>
-          </a:p>
-          <a:p>
-            <a:pPr>
-              <a:spcAft>
-                <a:spcPts val="600"/>
-              </a:spcAft>
-            </a:pPr>
-            <a:r>
-              <a:rPr sz="3200">
-                <a:solidFill>
-                  <a:srgbClr val="FFFFFF"/>
-                </a:solidFill>
-                <a:latin typeface="Arial"/>
-              </a:rPr>
-              <a:t>• ASP.NET Core API with options chain services</a:t>
-            </a:r>
-          </a:p>
-          <a:p>
-            <a:pPr>
-              <a:spcAft>
-                <a:spcPts val="600"/>
-              </a:spcAft>
-            </a:pPr>
-            <a:r>
-              <a:rPr sz="3200">
-                <a:solidFill>
-                  <a:srgbClr val="FFFFFF"/>
-                </a:solidFill>
-                <a:latin typeface="Arial"/>
-              </a:rPr>
-              <a:t>• GitHub Actions CI/CD + Husky.Net pre-commit hooks</a:t>
-            </a:r>
-          </a:p>
-        </p:txBody>
-      </p:sp>
-      <p:sp>
-        <p:nvSpPr>
-          <p:cNvPr id="62" name="Rectangle 61"/>
+              <a:t>3-tier: UI → Core → API</a:t>
+            </a:r>
+          </a:p>
+        </p:txBody>
+      </p:sp>
+      <p:sp>
+        <p:nvSpPr>
+          <p:cNvPr id="63" name="Rectangle 62"/>
           <p:cNvSpPr/>
           <p:nvPr/>
         </p:nvSpPr>
         <p:spPr>
           <a:xfrm>
-            <a:off x="14173200" y="3200400"/>
-            <a:ext cx="182880" cy="640080"/>
+            <a:off x="1371600" y="15819120"/>
+            <a:ext cx="10972800" cy="685800"/>
+          </a:xfrm>
+          <a:prstGeom prst="rect">
+            <a:avLst/>
+          </a:prstGeom>
+          <a:solidFill>
+            <a:srgbClr val="1A1A1A"/>
+          </a:solidFill>
+          <a:ln>
+            <a:noFill/>
+          </a:ln>
+          <a:effectLst/>
+        </p:spPr>
+        <p:style>
+          <a:lnRef idx="1">
+            <a:schemeClr val="accent1"/>
+          </a:lnRef>
+          <a:fillRef idx="3">
+            <a:schemeClr val="accent1"/>
+          </a:fillRef>
+          <a:effectRef idx="2">
+            <a:schemeClr val="accent1"/>
+          </a:effectRef>
+          <a:fontRef idx="minor">
+            <a:schemeClr val="lt1"/>
+          </a:fontRef>
+        </p:style>
+        <p:txBody>
+          <a:bodyPr rtlCol="0" anchor="ctr"/>
+          <a:lstStyle/>
+          <a:p>
+            <a:pPr algn="ctr"/>
+          </a:p>
+        </p:txBody>
+      </p:sp>
+      <p:sp>
+        <p:nvSpPr>
+          <p:cNvPr id="64" name="Rectangle 63"/>
+          <p:cNvSpPr/>
+          <p:nvPr/>
+        </p:nvSpPr>
+        <p:spPr>
+          <a:xfrm>
+            <a:off x="1371600" y="15819120"/>
+            <a:ext cx="182880" cy="685800"/>
           </a:xfrm>
           <a:prstGeom prst="rect">
             <a:avLst/>
@@ -2582,14 +2606,14 @@
       </p:sp>
       <p:sp>
         <p:nvSpPr>
-          <p:cNvPr id="63" name="TextBox 62"/>
+          <p:cNvPr id="65" name="TextBox 64"/>
           <p:cNvSpPr txBox="1"/>
           <p:nvPr/>
         </p:nvSpPr>
         <p:spPr>
           <a:xfrm>
-            <a:off x="14538960" y="3182112"/>
-            <a:ext cx="13533120" cy="640080"/>
+            <a:off x="1737360" y="15864840"/>
+            <a:ext cx="10515600" cy="594360"/>
           </a:xfrm>
           <a:prstGeom prst="rect">
             <a:avLst/>
@@ -2602,39 +2626,155 @@
           <a:p>
             <a:pPr algn="l"/>
             <a:r>
-              <a:rPr sz="4800" b="1">
+              <a:rPr sz="4400" b="1">
                 <a:solidFill>
                   <a:srgbClr val="FFFFFF"/>
                 </a:solidFill>
                 <a:latin typeface="Arial"/>
               </a:rPr>
-              <a:t>GEX Visualizer</a:t>
-            </a:r>
-          </a:p>
-        </p:txBody>
-      </p:sp>
-      <p:sp>
-        <p:nvSpPr>
-          <p:cNvPr id="64" name="Rounded Rectangle 63"/>
+              <a:t>Technology Stack</a:t>
+            </a:r>
+          </a:p>
+        </p:txBody>
+      </p:sp>
+      <p:sp>
+        <p:nvSpPr>
+          <p:cNvPr id="66" name="TextBox 65"/>
+          <p:cNvSpPr txBox="1"/>
+          <p:nvPr/>
+        </p:nvSpPr>
+        <p:spPr>
+          <a:xfrm>
+            <a:off x="1554480" y="16642080"/>
+            <a:ext cx="10607040" cy="3383279"/>
+          </a:xfrm>
+          <a:prstGeom prst="rect">
+            <a:avLst/>
+          </a:prstGeom>
+          <a:noFill/>
+        </p:spPr>
+        <p:txBody>
+          <a:bodyPr wrap="square">
+            <a:spAutoFit/>
+          </a:bodyPr>
+          <a:lstStyle/>
+          <a:p>
+            <a:pPr>
+              <a:spcAft>
+                <a:spcPts val="600"/>
+              </a:spcAft>
+            </a:pPr>
+            <a:r>
+              <a:rPr sz="3200">
+                <a:solidFill>
+                  <a:srgbClr val="2D2D2D"/>
+                </a:solidFill>
+                <a:latin typeface="Arial"/>
+              </a:rPr>
+              <a:t>• .NET 10 / Blazor WebAssembly (runs in browser via WASM)</a:t>
+            </a:r>
+          </a:p>
+          <a:p>
+            <a:pPr>
+              <a:spcAft>
+                <a:spcPts val="600"/>
+              </a:spcAft>
+            </a:pPr>
+            <a:r>
+              <a:rPr sz="3200">
+                <a:solidFill>
+                  <a:srgbClr val="2D2D2D"/>
+                </a:solidFill>
+                <a:latin typeface="Arial"/>
+              </a:rPr>
+              <a:t>• C# throughout — replaced JS/Python prototype entirely</a:t>
+            </a:r>
+          </a:p>
+          <a:p>
+            <a:pPr>
+              <a:spcAft>
+                <a:spcPts val="600"/>
+              </a:spcAft>
+            </a:pPr>
+            <a:r>
+              <a:rPr sz="3200">
+                <a:solidFill>
+                  <a:srgbClr val="2D2D2D"/>
+                </a:solidFill>
+                <a:latin typeface="Arial"/>
+              </a:rPr>
+              <a:t>• ApexCharts for interactive financial visualizations</a:t>
+            </a:r>
+          </a:p>
+          <a:p>
+            <a:pPr>
+              <a:spcAft>
+                <a:spcPts val="600"/>
+              </a:spcAft>
+            </a:pPr>
+            <a:r>
+              <a:rPr sz="3200">
+                <a:solidFill>
+                  <a:srgbClr val="2D2D2D"/>
+                </a:solidFill>
+                <a:latin typeface="Arial"/>
+              </a:rPr>
+              <a:t>• SQLite caching layer for market data persistence</a:t>
+            </a:r>
+          </a:p>
+          <a:p>
+            <a:pPr>
+              <a:spcAft>
+                <a:spcPts val="600"/>
+              </a:spcAft>
+            </a:pPr>
+            <a:r>
+              <a:rPr sz="3200">
+                <a:solidFill>
+                  <a:srgbClr val="2D2D2D"/>
+                </a:solidFill>
+                <a:latin typeface="Arial"/>
+              </a:rPr>
+              <a:t>• ASP.NET Core API with options chain services</a:t>
+            </a:r>
+          </a:p>
+          <a:p>
+            <a:pPr>
+              <a:spcAft>
+                <a:spcPts val="600"/>
+              </a:spcAft>
+            </a:pPr>
+            <a:r>
+              <a:rPr sz="3200">
+                <a:solidFill>
+                  <a:srgbClr val="2D2D2D"/>
+                </a:solidFill>
+                <a:latin typeface="Arial"/>
+              </a:rPr>
+              <a:t>• GitHub Actions CI/CD + Husky.Net pre-commit hooks</a:t>
+            </a:r>
+          </a:p>
+        </p:txBody>
+      </p:sp>
+      <p:sp>
+        <p:nvSpPr>
+          <p:cNvPr id="67" name="Rectangle 66"/>
           <p:cNvSpPr/>
           <p:nvPr/>
         </p:nvSpPr>
         <p:spPr>
           <a:xfrm>
-            <a:off x="14173200" y="3977640"/>
-            <a:ext cx="13898880" cy="5943600"/>
-          </a:xfrm>
-          <a:prstGeom prst="roundRect">
+            <a:off x="14173200" y="3200400"/>
+            <a:ext cx="13898880" cy="685800"/>
+          </a:xfrm>
+          <a:prstGeom prst="rect">
             <a:avLst/>
           </a:prstGeom>
           <a:solidFill>
-            <a:srgbClr val="E8E8E8"/>
+            <a:srgbClr val="1A1A1A"/>
           </a:solidFill>
-          <a:ln w="25400">
-            <a:solidFill>
-              <a:srgbClr val="666666"/>
-            </a:solidFill>
-            <a:prstDash val="dash"/>
+          <a:ln>
+            <a:noFill/>
           </a:ln>
           <a:effectLst/>
         </p:spPr>
@@ -2662,80 +2802,14 @@
       </p:sp>
       <p:sp>
         <p:nvSpPr>
-          <p:cNvPr id="65" name="TextBox 64"/>
-          <p:cNvSpPr txBox="1"/>
-          <p:nvPr/>
-        </p:nvSpPr>
-        <p:spPr>
-          <a:xfrm>
-            <a:off x="14173200" y="6537960"/>
-            <a:ext cx="13898880" cy="548640"/>
-          </a:xfrm>
-          <a:prstGeom prst="rect">
-            <a:avLst/>
-          </a:prstGeom>
-          <a:noFill/>
-        </p:spPr>
-        <p:txBody>
-          <a:bodyPr wrap="square"/>
-          <a:lstStyle/>
-          <a:p>
-            <a:pPr algn="ctr"/>
-            <a:r>
-              <a:rPr sz="3600" b="1">
-                <a:solidFill>
-                  <a:srgbClr val="666666"/>
-                </a:solidFill>
-                <a:latin typeface="Arial"/>
-              </a:rPr>
-              <a:t>GEX VISUALIZER</a:t>
-            </a:r>
-          </a:p>
-        </p:txBody>
-      </p:sp>
-      <p:sp>
-        <p:nvSpPr>
-          <p:cNvPr id="66" name="TextBox 65"/>
-          <p:cNvSpPr txBox="1"/>
-          <p:nvPr/>
-        </p:nvSpPr>
-        <p:spPr>
-          <a:xfrm>
-            <a:off x="14173200" y="7132320"/>
-            <a:ext cx="13898880" cy="457200"/>
-          </a:xfrm>
-          <a:prstGeom prst="rect">
-            <a:avLst/>
-          </a:prstGeom>
-          <a:noFill/>
-        </p:spPr>
-        <p:txBody>
-          <a:bodyPr wrap="square"/>
-          <a:lstStyle/>
-          <a:p>
-            <a:pPr algn="ctr"/>
-            <a:r>
-              <a:rPr sz="2200" b="0">
-                <a:solidFill>
-                  <a:srgbClr val="666666"/>
-                </a:solidFill>
-                <a:latin typeface="Arial"/>
-              </a:rPr>
-              <a:t>Interactive chart + regime timeline + annotations</a:t>
-            </a:r>
-          </a:p>
-        </p:txBody>
-      </p:sp>
-      <p:sp>
-        <p:nvSpPr>
-          <p:cNvPr id="67" name="Rectangle 66"/>
+          <p:cNvPr id="68" name="Rectangle 67"/>
           <p:cNvSpPr/>
           <p:nvPr/>
         </p:nvSpPr>
         <p:spPr>
           <a:xfrm>
-            <a:off x="14173200" y="10287000"/>
-            <a:ext cx="182880" cy="640080"/>
+            <a:off x="14173200" y="3200400"/>
+            <a:ext cx="182880" cy="685800"/>
           </a:xfrm>
           <a:prstGeom prst="rect">
             <a:avLst/>
@@ -2772,14 +2846,14 @@
       </p:sp>
       <p:sp>
         <p:nvSpPr>
-          <p:cNvPr id="68" name="TextBox 67"/>
+          <p:cNvPr id="69" name="TextBox 68"/>
           <p:cNvSpPr txBox="1"/>
           <p:nvPr/>
         </p:nvSpPr>
         <p:spPr>
           <a:xfrm>
-            <a:off x="14538960" y="10268712"/>
-            <a:ext cx="13533120" cy="640080"/>
+            <a:off x="14538960" y="3246120"/>
+            <a:ext cx="13441680" cy="594360"/>
           </a:xfrm>
           <a:prstGeom prst="rect">
             <a:avLst/>
@@ -2792,37 +2866,37 @@
           <a:p>
             <a:pPr algn="l"/>
             <a:r>
-              <a:rPr sz="4800" b="1">
+              <a:rPr sz="4400" b="1">
                 <a:solidFill>
                   <a:srgbClr val="FFFFFF"/>
                 </a:solidFill>
                 <a:latin typeface="Arial"/>
               </a:rPr>
-              <a:t>Research Notebook</a:t>
-            </a:r>
-          </a:p>
-        </p:txBody>
-      </p:sp>
-      <p:sp>
-        <p:nvSpPr>
-          <p:cNvPr id="69" name="Rounded Rectangle 68"/>
+              <a:t>GEX Visualizer</a:t>
+            </a:r>
+          </a:p>
+        </p:txBody>
+      </p:sp>
+      <p:sp>
+        <p:nvSpPr>
+          <p:cNvPr id="70" name="Rounded Rectangle 69"/>
           <p:cNvSpPr/>
           <p:nvPr/>
         </p:nvSpPr>
         <p:spPr>
           <a:xfrm>
-            <a:off x="14173200" y="11064240"/>
-            <a:ext cx="13898880" cy="5486400"/>
+            <a:off x="14173200" y="4023360"/>
+            <a:ext cx="13898880" cy="5943600"/>
           </a:xfrm>
           <a:prstGeom prst="roundRect">
             <a:avLst/>
           </a:prstGeom>
           <a:solidFill>
-            <a:srgbClr val="E8E8E8"/>
+            <a:srgbClr val="ECECEC"/>
           </a:solidFill>
-          <a:ln w="25400">
+          <a:ln w="19050">
             <a:solidFill>
-              <a:srgbClr val="666666"/>
+              <a:srgbClr val="AAAAAA"/>
             </a:solidFill>
             <a:prstDash val="dash"/>
           </a:ln>
@@ -2852,46 +2926,46 @@
       </p:sp>
       <p:sp>
         <p:nvSpPr>
-          <p:cNvPr id="70" name="TextBox 69"/>
-          <p:cNvSpPr txBox="1"/>
-          <p:nvPr/>
-        </p:nvSpPr>
-        <p:spPr>
-          <a:xfrm>
-            <a:off x="14173200" y="13395960"/>
-            <a:ext cx="13898880" cy="548640"/>
-          </a:xfrm>
-          <a:prstGeom prst="rect">
-            <a:avLst/>
-          </a:prstGeom>
-          <a:noFill/>
-        </p:spPr>
-        <p:txBody>
-          <a:bodyPr wrap="square"/>
-          <a:lstStyle/>
-          <a:p>
-            <a:pPr algn="ctr"/>
-            <a:r>
-              <a:rPr sz="3600" b="1">
-                <a:solidFill>
-                  <a:srgbClr val="666666"/>
-                </a:solidFill>
-                <a:latin typeface="Arial"/>
-              </a:rPr>
-              <a:t>RESEARCH NOTEBOOK</a:t>
-            </a:r>
-          </a:p>
-        </p:txBody>
-      </p:sp>
-      <p:sp>
-        <p:nvSpPr>
           <p:cNvPr id="71" name="TextBox 70"/>
           <p:cNvSpPr txBox="1"/>
           <p:nvPr/>
         </p:nvSpPr>
         <p:spPr>
           <a:xfrm>
-            <a:off x="14173200" y="13990320"/>
+            <a:off x="14173200" y="6583680"/>
+            <a:ext cx="13898880" cy="548640"/>
+          </a:xfrm>
+          <a:prstGeom prst="rect">
+            <a:avLst/>
+          </a:prstGeom>
+          <a:noFill/>
+        </p:spPr>
+        <p:txBody>
+          <a:bodyPr wrap="square"/>
+          <a:lstStyle/>
+          <a:p>
+            <a:pPr algn="ctr"/>
+            <a:r>
+              <a:rPr sz="3600" b="1">
+                <a:solidFill>
+                  <a:srgbClr val="AAAAAA"/>
+                </a:solidFill>
+                <a:latin typeface="Arial"/>
+              </a:rPr>
+              <a:t>GEX VISUALIZER</a:t>
+            </a:r>
+          </a:p>
+        </p:txBody>
+      </p:sp>
+      <p:sp>
+        <p:nvSpPr>
+          <p:cNvPr id="72" name="TextBox 71"/>
+          <p:cNvSpPr txBox="1"/>
+          <p:nvPr/>
+        </p:nvSpPr>
+        <p:spPr>
+          <a:xfrm>
+            <a:off x="14173200" y="7178040"/>
             <a:ext cx="13898880" cy="457200"/>
           </a:xfrm>
           <a:prstGeom prst="rect">
@@ -2907,25 +2981,69 @@
             <a:r>
               <a:rPr sz="2200" b="0">
                 <a:solidFill>
-                  <a:srgbClr val="666666"/>
+                  <a:srgbClr val="AAAAAA"/>
                 </a:solidFill>
                 <a:latin typeface="Arial"/>
               </a:rPr>
-              <a:t>KDD process tracking + complexity radar</a:t>
-            </a:r>
-          </a:p>
-        </p:txBody>
-      </p:sp>
-      <p:sp>
-        <p:nvSpPr>
-          <p:cNvPr id="72" name="Rectangle 71"/>
+              <a:t>Interactive chart + regime timeline + annotations</a:t>
+            </a:r>
+          </a:p>
+        </p:txBody>
+      </p:sp>
+      <p:sp>
+        <p:nvSpPr>
+          <p:cNvPr id="73" name="Rectangle 72"/>
           <p:cNvSpPr/>
           <p:nvPr/>
         </p:nvSpPr>
         <p:spPr>
           <a:xfrm>
-            <a:off x="14173200" y="16916400"/>
-            <a:ext cx="182880" cy="640080"/>
+            <a:off x="14173200" y="10332720"/>
+            <a:ext cx="13898880" cy="685800"/>
+          </a:xfrm>
+          <a:prstGeom prst="rect">
+            <a:avLst/>
+          </a:prstGeom>
+          <a:solidFill>
+            <a:srgbClr val="1A1A1A"/>
+          </a:solidFill>
+          <a:ln>
+            <a:noFill/>
+          </a:ln>
+          <a:effectLst/>
+        </p:spPr>
+        <p:style>
+          <a:lnRef idx="1">
+            <a:schemeClr val="accent1"/>
+          </a:lnRef>
+          <a:fillRef idx="3">
+            <a:schemeClr val="accent1"/>
+          </a:fillRef>
+          <a:effectRef idx="2">
+            <a:schemeClr val="accent1"/>
+          </a:effectRef>
+          <a:fontRef idx="minor">
+            <a:schemeClr val="lt1"/>
+          </a:fontRef>
+        </p:style>
+        <p:txBody>
+          <a:bodyPr rtlCol="0" anchor="ctr"/>
+          <a:lstStyle/>
+          <a:p>
+            <a:pPr algn="ctr"/>
+          </a:p>
+        </p:txBody>
+      </p:sp>
+      <p:sp>
+        <p:nvSpPr>
+          <p:cNvPr id="74" name="Rectangle 73"/>
+          <p:cNvSpPr/>
+          <p:nvPr/>
+        </p:nvSpPr>
+        <p:spPr>
+          <a:xfrm>
+            <a:off x="14173200" y="10332720"/>
+            <a:ext cx="182880" cy="685800"/>
           </a:xfrm>
           <a:prstGeom prst="rect">
             <a:avLst/>
@@ -2962,14 +3080,14 @@
       </p:sp>
       <p:sp>
         <p:nvSpPr>
-          <p:cNvPr id="73" name="TextBox 72"/>
+          <p:cNvPr id="75" name="TextBox 74"/>
           <p:cNvSpPr txBox="1"/>
           <p:nvPr/>
         </p:nvSpPr>
         <p:spPr>
           <a:xfrm>
-            <a:off x="14538960" y="16898112"/>
-            <a:ext cx="13533120" cy="640080"/>
+            <a:off x="14538960" y="10378440"/>
+            <a:ext cx="13441680" cy="594360"/>
           </a:xfrm>
           <a:prstGeom prst="rect">
             <a:avLst/>
@@ -2982,37 +3100,37 @@
           <a:p>
             <a:pPr algn="l"/>
             <a:r>
-              <a:rPr sz="4800" b="1">
+              <a:rPr sz="4400" b="1">
                 <a:solidFill>
                   <a:srgbClr val="FFFFFF"/>
                 </a:solidFill>
                 <a:latin typeface="Arial"/>
               </a:rPr>
-              <a:t>Paper Trading Journal</a:t>
-            </a:r>
-          </a:p>
-        </p:txBody>
-      </p:sp>
-      <p:sp>
-        <p:nvSpPr>
-          <p:cNvPr id="74" name="Rounded Rectangle 73"/>
+              <a:t>Research Notebook</a:t>
+            </a:r>
+          </a:p>
+        </p:txBody>
+      </p:sp>
+      <p:sp>
+        <p:nvSpPr>
+          <p:cNvPr id="76" name="Rounded Rectangle 75"/>
           <p:cNvSpPr/>
           <p:nvPr/>
         </p:nvSpPr>
         <p:spPr>
           <a:xfrm>
-            <a:off x="14173200" y="17693640"/>
+            <a:off x="14173200" y="11155680"/>
             <a:ext cx="13898880" cy="5486400"/>
           </a:xfrm>
           <a:prstGeom prst="roundRect">
             <a:avLst/>
           </a:prstGeom>
           <a:solidFill>
-            <a:srgbClr val="E8E8E8"/>
+            <a:srgbClr val="ECECEC"/>
           </a:solidFill>
-          <a:ln w="25400">
+          <a:ln w="19050">
             <a:solidFill>
-              <a:srgbClr val="666666"/>
+              <a:srgbClr val="AAAAAA"/>
             </a:solidFill>
             <a:prstDash val="dash"/>
           </a:ln>
@@ -3042,79 +3160,13 @@
       </p:sp>
       <p:sp>
         <p:nvSpPr>
-          <p:cNvPr id="75" name="TextBox 74"/>
-          <p:cNvSpPr txBox="1"/>
-          <p:nvPr/>
-        </p:nvSpPr>
-        <p:spPr>
-          <a:xfrm>
-            <a:off x="14173200" y="20025360"/>
-            <a:ext cx="13898880" cy="548640"/>
-          </a:xfrm>
-          <a:prstGeom prst="rect">
-            <a:avLst/>
-          </a:prstGeom>
-          <a:noFill/>
-        </p:spPr>
-        <p:txBody>
-          <a:bodyPr wrap="square"/>
-          <a:lstStyle/>
-          <a:p>
-            <a:pPr algn="ctr"/>
-            <a:r>
-              <a:rPr sz="3600" b="1">
-                <a:solidFill>
-                  <a:srgbClr val="666666"/>
-                </a:solidFill>
-                <a:latin typeface="Arial"/>
-              </a:rPr>
-              <a:t>PAPER TRADING</a:t>
-            </a:r>
-          </a:p>
-        </p:txBody>
-      </p:sp>
-      <p:sp>
-        <p:nvSpPr>
-          <p:cNvPr id="76" name="TextBox 75"/>
-          <p:cNvSpPr txBox="1"/>
-          <p:nvPr/>
-        </p:nvSpPr>
-        <p:spPr>
-          <a:xfrm>
-            <a:off x="14173200" y="20619720"/>
-            <a:ext cx="13898880" cy="457200"/>
-          </a:xfrm>
-          <a:prstGeom prst="rect">
-            <a:avLst/>
-          </a:prstGeom>
-          <a:noFill/>
-        </p:spPr>
-        <p:txBody>
-          <a:bodyPr wrap="square"/>
-          <a:lstStyle/>
-          <a:p>
-            <a:pPr algn="ctr"/>
-            <a:r>
-              <a:rPr sz="2200" b="0">
-                <a:solidFill>
-                  <a:srgbClr val="666666"/>
-                </a:solidFill>
-                <a:latin typeface="Arial"/>
-              </a:rPr>
-              <a:t>Trade grid + decision timeline + regime context</a:t>
-            </a:r>
-          </a:p>
-        </p:txBody>
-      </p:sp>
-      <p:sp>
-        <p:nvSpPr>
           <p:cNvPr id="77" name="TextBox 76"/>
           <p:cNvSpPr txBox="1"/>
           <p:nvPr/>
         </p:nvSpPr>
         <p:spPr>
           <a:xfrm>
-            <a:off x="14173200" y="23545800"/>
+            <a:off x="14173200" y="13487400"/>
             <a:ext cx="13898880" cy="548640"/>
           </a:xfrm>
           <a:prstGeom prst="rect">
@@ -3128,27 +3180,104 @@
           <a:p>
             <a:pPr algn="ctr"/>
             <a:r>
-              <a:rPr sz="2800" b="0">
-                <a:solidFill>
-                  <a:srgbClr val="FFC000"/>
+              <a:rPr sz="3600" b="1">
+                <a:solidFill>
+                  <a:srgbClr val="AAAAAA"/>
                 </a:solidFill>
                 <a:latin typeface="Arial"/>
               </a:rPr>
-              <a:t>15 pages  •  35+ Blazor components  •  Full keyboard navigation</a:t>
-            </a:r>
-          </a:p>
-        </p:txBody>
-      </p:sp>
-      <p:sp>
-        <p:nvSpPr>
-          <p:cNvPr id="78" name="Rectangle 77"/>
+              <a:t>RESEARCH NOTEBOOK</a:t>
+            </a:r>
+          </a:p>
+        </p:txBody>
+      </p:sp>
+      <p:sp>
+        <p:nvSpPr>
+          <p:cNvPr id="78" name="TextBox 77"/>
+          <p:cNvSpPr txBox="1"/>
+          <p:nvPr/>
+        </p:nvSpPr>
+        <p:spPr>
+          <a:xfrm>
+            <a:off x="14173200" y="14081760"/>
+            <a:ext cx="13898880" cy="457200"/>
+          </a:xfrm>
+          <a:prstGeom prst="rect">
+            <a:avLst/>
+          </a:prstGeom>
+          <a:noFill/>
+        </p:spPr>
+        <p:txBody>
+          <a:bodyPr wrap="square"/>
+          <a:lstStyle/>
+          <a:p>
+            <a:pPr algn="ctr"/>
+            <a:r>
+              <a:rPr sz="2200" b="0">
+                <a:solidFill>
+                  <a:srgbClr val="AAAAAA"/>
+                </a:solidFill>
+                <a:latin typeface="Arial"/>
+              </a:rPr>
+              <a:t>KDD process tracking + complexity radar</a:t>
+            </a:r>
+          </a:p>
+        </p:txBody>
+      </p:sp>
+      <p:sp>
+        <p:nvSpPr>
+          <p:cNvPr id="79" name="Rectangle 78"/>
           <p:cNvSpPr/>
           <p:nvPr/>
         </p:nvSpPr>
         <p:spPr>
           <a:xfrm>
-            <a:off x="28620720" y="3200400"/>
-            <a:ext cx="182880" cy="640080"/>
+            <a:off x="14173200" y="17007840"/>
+            <a:ext cx="13898880" cy="685800"/>
+          </a:xfrm>
+          <a:prstGeom prst="rect">
+            <a:avLst/>
+          </a:prstGeom>
+          <a:solidFill>
+            <a:srgbClr val="1A1A1A"/>
+          </a:solidFill>
+          <a:ln>
+            <a:noFill/>
+          </a:ln>
+          <a:effectLst/>
+        </p:spPr>
+        <p:style>
+          <a:lnRef idx="1">
+            <a:schemeClr val="accent1"/>
+          </a:lnRef>
+          <a:fillRef idx="3">
+            <a:schemeClr val="accent1"/>
+          </a:fillRef>
+          <a:effectRef idx="2">
+            <a:schemeClr val="accent1"/>
+          </a:effectRef>
+          <a:fontRef idx="minor">
+            <a:schemeClr val="lt1"/>
+          </a:fontRef>
+        </p:style>
+        <p:txBody>
+          <a:bodyPr rtlCol="0" anchor="ctr"/>
+          <a:lstStyle/>
+          <a:p>
+            <a:pPr algn="ctr"/>
+          </a:p>
+        </p:txBody>
+      </p:sp>
+      <p:sp>
+        <p:nvSpPr>
+          <p:cNvPr id="80" name="Rectangle 79"/>
+          <p:cNvSpPr/>
+          <p:nvPr/>
+        </p:nvSpPr>
+        <p:spPr>
+          <a:xfrm>
+            <a:off x="14173200" y="17007840"/>
+            <a:ext cx="182880" cy="685800"/>
           </a:xfrm>
           <a:prstGeom prst="rect">
             <a:avLst/>
@@ -3185,14 +3314,14 @@
       </p:sp>
       <p:sp>
         <p:nvSpPr>
-          <p:cNvPr id="79" name="TextBox 78"/>
+          <p:cNvPr id="81" name="TextBox 80"/>
           <p:cNvSpPr txBox="1"/>
           <p:nvPr/>
         </p:nvSpPr>
         <p:spPr>
           <a:xfrm>
-            <a:off x="28986480" y="3182112"/>
-            <a:ext cx="13533120" cy="640080"/>
+            <a:off x="14538960" y="17053560"/>
+            <a:ext cx="13441680" cy="594360"/>
           </a:xfrm>
           <a:prstGeom prst="rect">
             <a:avLst/>
@@ -3205,37 +3334,37 @@
           <a:p>
             <a:pPr algn="l"/>
             <a:r>
-              <a:rPr sz="4800" b="1">
+              <a:rPr sz="4400" b="1">
                 <a:solidFill>
                   <a:srgbClr val="FFFFFF"/>
                 </a:solidFill>
                 <a:latin typeface="Arial"/>
               </a:rPr>
-              <a:t>Research Arcade</a:t>
-            </a:r>
-          </a:p>
-        </p:txBody>
-      </p:sp>
-      <p:sp>
-        <p:nvSpPr>
-          <p:cNvPr id="80" name="Rounded Rectangle 79"/>
+              <a:t>Paper Trading Journal</a:t>
+            </a:r>
+          </a:p>
+        </p:txBody>
+      </p:sp>
+      <p:sp>
+        <p:nvSpPr>
+          <p:cNvPr id="82" name="Rounded Rectangle 81"/>
           <p:cNvSpPr/>
           <p:nvPr/>
         </p:nvSpPr>
         <p:spPr>
           <a:xfrm>
-            <a:off x="28620720" y="3977640"/>
-            <a:ext cx="13898880" cy="5029200"/>
+            <a:off x="14173200" y="17830800"/>
+            <a:ext cx="13898880" cy="5486400"/>
           </a:xfrm>
           <a:prstGeom prst="roundRect">
             <a:avLst/>
           </a:prstGeom>
           <a:solidFill>
-            <a:srgbClr val="E8E8E8"/>
+            <a:srgbClr val="ECECEC"/>
           </a:solidFill>
-          <a:ln w="25400">
+          <a:ln w="19050">
             <a:solidFill>
-              <a:srgbClr val="666666"/>
+              <a:srgbClr val="AAAAAA"/>
             </a:solidFill>
             <a:prstDash val="dash"/>
           </a:ln>
@@ -3265,13 +3394,13 @@
       </p:sp>
       <p:sp>
         <p:nvSpPr>
-          <p:cNvPr id="81" name="TextBox 80"/>
+          <p:cNvPr id="83" name="TextBox 82"/>
           <p:cNvSpPr txBox="1"/>
           <p:nvPr/>
         </p:nvSpPr>
         <p:spPr>
           <a:xfrm>
-            <a:off x="28620720" y="6080760"/>
+            <a:off x="14173200" y="20162520"/>
             <a:ext cx="13898880" cy="548640"/>
           </a:xfrm>
           <a:prstGeom prst="rect">
@@ -3287,24 +3416,24 @@
             <a:r>
               <a:rPr sz="3600" b="1">
                 <a:solidFill>
-                  <a:srgbClr val="666666"/>
+                  <a:srgbClr val="AAAAAA"/>
                 </a:solidFill>
                 <a:latin typeface="Arial"/>
               </a:rPr>
-              <a:t>RESEARCH ARCADE</a:t>
-            </a:r>
-          </a:p>
-        </p:txBody>
-      </p:sp>
-      <p:sp>
-        <p:nvSpPr>
-          <p:cNvPr id="82" name="TextBox 81"/>
+              <a:t>PAPER TRADING</a:t>
+            </a:r>
+          </a:p>
+        </p:txBody>
+      </p:sp>
+      <p:sp>
+        <p:nvSpPr>
+          <p:cNvPr id="84" name="TextBox 83"/>
           <p:cNvSpPr txBox="1"/>
           <p:nvPr/>
         </p:nvSpPr>
         <p:spPr>
           <a:xfrm>
-            <a:off x="28620720" y="6675120"/>
+            <a:off x="14173200" y="20756880"/>
             <a:ext cx="13898880" cy="457200"/>
           </a:xfrm>
           <a:prstGeom prst="rect">
@@ -3320,25 +3449,102 @@
             <a:r>
               <a:rPr sz="2200" b="0">
                 <a:solidFill>
-                  <a:srgbClr val="666666"/>
+                  <a:srgbClr val="AAAAAA"/>
                 </a:solidFill>
                 <a:latin typeface="Arial"/>
               </a:rPr>
-              <a:t>Pattern discovery + data pipeline state</a:t>
-            </a:r>
-          </a:p>
-        </p:txBody>
-      </p:sp>
-      <p:sp>
-        <p:nvSpPr>
-          <p:cNvPr id="83" name="Rectangle 82"/>
+              <a:t>Trade grid + decision timeline + regime context</a:t>
+            </a:r>
+          </a:p>
+        </p:txBody>
+      </p:sp>
+      <p:sp>
+        <p:nvSpPr>
+          <p:cNvPr id="85" name="TextBox 84"/>
+          <p:cNvSpPr txBox="1"/>
+          <p:nvPr/>
+        </p:nvSpPr>
+        <p:spPr>
+          <a:xfrm>
+            <a:off x="14173200" y="23682960"/>
+            <a:ext cx="13898880" cy="548640"/>
+          </a:xfrm>
+          <a:prstGeom prst="rect">
+            <a:avLst/>
+          </a:prstGeom>
+          <a:noFill/>
+        </p:spPr>
+        <p:txBody>
+          <a:bodyPr wrap="square"/>
+          <a:lstStyle/>
+          <a:p>
+            <a:pPr algn="ctr"/>
+            <a:r>
+              <a:rPr sz="2800" b="1">
+                <a:solidFill>
+                  <a:srgbClr val="C48E00"/>
+                </a:solidFill>
+                <a:latin typeface="Arial"/>
+              </a:rPr>
+              <a:t>15 pages  •  35+ Blazor components  •  Full keyboard navigation</a:t>
+            </a:r>
+          </a:p>
+        </p:txBody>
+      </p:sp>
+      <p:sp>
+        <p:nvSpPr>
+          <p:cNvPr id="86" name="Rectangle 85"/>
           <p:cNvSpPr/>
           <p:nvPr/>
         </p:nvSpPr>
         <p:spPr>
           <a:xfrm>
-            <a:off x="28620720" y="9372600"/>
-            <a:ext cx="182880" cy="640080"/>
+            <a:off x="28620720" y="3200400"/>
+            <a:ext cx="13898880" cy="685800"/>
+          </a:xfrm>
+          <a:prstGeom prst="rect">
+            <a:avLst/>
+          </a:prstGeom>
+          <a:solidFill>
+            <a:srgbClr val="1A1A1A"/>
+          </a:solidFill>
+          <a:ln>
+            <a:noFill/>
+          </a:ln>
+          <a:effectLst/>
+        </p:spPr>
+        <p:style>
+          <a:lnRef idx="1">
+            <a:schemeClr val="accent1"/>
+          </a:lnRef>
+          <a:fillRef idx="3">
+            <a:schemeClr val="accent1"/>
+          </a:fillRef>
+          <a:effectRef idx="2">
+            <a:schemeClr val="accent1"/>
+          </a:effectRef>
+          <a:fontRef idx="minor">
+            <a:schemeClr val="lt1"/>
+          </a:fontRef>
+        </p:style>
+        <p:txBody>
+          <a:bodyPr rtlCol="0" anchor="ctr"/>
+          <a:lstStyle/>
+          <a:p>
+            <a:pPr algn="ctr"/>
+          </a:p>
+        </p:txBody>
+      </p:sp>
+      <p:sp>
+        <p:nvSpPr>
+          <p:cNvPr id="87" name="Rectangle 86"/>
+          <p:cNvSpPr/>
+          <p:nvPr/>
+        </p:nvSpPr>
+        <p:spPr>
+          <a:xfrm>
+            <a:off x="28620720" y="3200400"/>
+            <a:ext cx="182880" cy="685800"/>
           </a:xfrm>
           <a:prstGeom prst="rect">
             <a:avLst/>
@@ -3375,14 +3581,14 @@
       </p:sp>
       <p:sp>
         <p:nvSpPr>
-          <p:cNvPr id="84" name="TextBox 83"/>
+          <p:cNvPr id="88" name="TextBox 87"/>
           <p:cNvSpPr txBox="1"/>
           <p:nvPr/>
         </p:nvSpPr>
         <p:spPr>
           <a:xfrm>
-            <a:off x="28986480" y="9354312"/>
-            <a:ext cx="13533120" cy="640080"/>
+            <a:off x="28986480" y="3246120"/>
+            <a:ext cx="13441680" cy="594360"/>
           </a:xfrm>
           <a:prstGeom prst="rect">
             <a:avLst/>
@@ -3395,37 +3601,37 @@
           <a:p>
             <a:pPr algn="l"/>
             <a:r>
-              <a:rPr sz="4800" b="1">
+              <a:rPr sz="4400" b="1">
                 <a:solidFill>
                   <a:srgbClr val="FFFFFF"/>
                 </a:solidFill>
                 <a:latin typeface="Arial"/>
               </a:rPr>
-              <a:t>Task Board &amp; CI/CD</a:t>
-            </a:r>
-          </a:p>
-        </p:txBody>
-      </p:sp>
-      <p:sp>
-        <p:nvSpPr>
-          <p:cNvPr id="85" name="Rounded Rectangle 84"/>
+              <a:t>Research Arcade</a:t>
+            </a:r>
+          </a:p>
+        </p:txBody>
+      </p:sp>
+      <p:sp>
+        <p:nvSpPr>
+          <p:cNvPr id="89" name="Rounded Rectangle 88"/>
           <p:cNvSpPr/>
           <p:nvPr/>
         </p:nvSpPr>
         <p:spPr>
           <a:xfrm>
-            <a:off x="28620720" y="10149840"/>
-            <a:ext cx="6766560" cy="5029200"/>
+            <a:off x="28620720" y="4023360"/>
+            <a:ext cx="13898880" cy="5029200"/>
           </a:xfrm>
           <a:prstGeom prst="roundRect">
             <a:avLst/>
           </a:prstGeom>
           <a:solidFill>
-            <a:srgbClr val="E8E8E8"/>
+            <a:srgbClr val="ECECEC"/>
           </a:solidFill>
-          <a:ln w="25400">
+          <a:ln w="19050">
             <a:solidFill>
-              <a:srgbClr val="666666"/>
+              <a:srgbClr val="AAAAAA"/>
             </a:solidFill>
             <a:prstDash val="dash"/>
           </a:ln>
@@ -3455,14 +3661,14 @@
       </p:sp>
       <p:sp>
         <p:nvSpPr>
-          <p:cNvPr id="86" name="TextBox 85"/>
+          <p:cNvPr id="90" name="TextBox 89"/>
           <p:cNvSpPr txBox="1"/>
           <p:nvPr/>
         </p:nvSpPr>
         <p:spPr>
           <a:xfrm>
-            <a:off x="28620720" y="12252960"/>
-            <a:ext cx="6766560" cy="548640"/>
+            <a:off x="28620720" y="6126480"/>
+            <a:ext cx="13898880" cy="548640"/>
           </a:xfrm>
           <a:prstGeom prst="rect">
             <a:avLst/>
@@ -3477,25 +3683,25 @@
             <a:r>
               <a:rPr sz="3600" b="1">
                 <a:solidFill>
-                  <a:srgbClr val="666666"/>
+                  <a:srgbClr val="AAAAAA"/>
                 </a:solidFill>
                 <a:latin typeface="Arial"/>
               </a:rPr>
-              <a:t>TASK BOARD</a:t>
-            </a:r>
-          </a:p>
-        </p:txBody>
-      </p:sp>
-      <p:sp>
-        <p:nvSpPr>
-          <p:cNvPr id="87" name="TextBox 86"/>
+              <a:t>RESEARCH ARCADE</a:t>
+            </a:r>
+          </a:p>
+        </p:txBody>
+      </p:sp>
+      <p:sp>
+        <p:nvSpPr>
+          <p:cNvPr id="91" name="TextBox 90"/>
           <p:cNvSpPr txBox="1"/>
           <p:nvPr/>
         </p:nvSpPr>
         <p:spPr>
           <a:xfrm>
-            <a:off x="28620720" y="12847320"/>
-            <a:ext cx="6766560" cy="457200"/>
+            <a:off x="28620720" y="6720840"/>
+            <a:ext cx="13898880" cy="457200"/>
           </a:xfrm>
           <a:prstGeom prst="rect">
             <a:avLst/>
@@ -3510,37 +3716,34 @@
             <a:r>
               <a:rPr sz="2200" b="0">
                 <a:solidFill>
-                  <a:srgbClr val="666666"/>
+                  <a:srgbClr val="AAAAAA"/>
                 </a:solidFill>
                 <a:latin typeface="Arial"/>
               </a:rPr>
-              <a:t>GitHub Kanban</a:t>
-            </a:r>
-          </a:p>
-        </p:txBody>
-      </p:sp>
-      <p:sp>
-        <p:nvSpPr>
-          <p:cNvPr id="88" name="Rounded Rectangle 87"/>
+              <a:t>Pattern discovery + data pipeline state</a:t>
+            </a:r>
+          </a:p>
+        </p:txBody>
+      </p:sp>
+      <p:sp>
+        <p:nvSpPr>
+          <p:cNvPr id="92" name="Rectangle 91"/>
           <p:cNvSpPr/>
           <p:nvPr/>
         </p:nvSpPr>
         <p:spPr>
           <a:xfrm>
-            <a:off x="35753040" y="10149840"/>
-            <a:ext cx="6766560" cy="5029200"/>
-          </a:xfrm>
-          <a:prstGeom prst="roundRect">
+            <a:off x="28620720" y="9418320"/>
+            <a:ext cx="13898880" cy="685800"/>
+          </a:xfrm>
+          <a:prstGeom prst="rect">
             <a:avLst/>
           </a:prstGeom>
           <a:solidFill>
-            <a:srgbClr val="E8E8E8"/>
+            <a:srgbClr val="1A1A1A"/>
           </a:solidFill>
-          <a:ln w="25400">
-            <a:solidFill>
-              <a:srgbClr val="666666"/>
-            </a:solidFill>
-            <a:prstDash val="dash"/>
+          <a:ln>
+            <a:noFill/>
           </a:ln>
           <a:effectLst/>
         </p:spPr>
@@ -3568,80 +3771,14 @@
       </p:sp>
       <p:sp>
         <p:nvSpPr>
-          <p:cNvPr id="89" name="TextBox 88"/>
-          <p:cNvSpPr txBox="1"/>
-          <p:nvPr/>
-        </p:nvSpPr>
-        <p:spPr>
-          <a:xfrm>
-            <a:off x="35753040" y="12252960"/>
-            <a:ext cx="6766560" cy="548640"/>
-          </a:xfrm>
-          <a:prstGeom prst="rect">
-            <a:avLst/>
-          </a:prstGeom>
-          <a:noFill/>
-        </p:spPr>
-        <p:txBody>
-          <a:bodyPr wrap="square"/>
-          <a:lstStyle/>
-          <a:p>
-            <a:pPr algn="ctr"/>
-            <a:r>
-              <a:rPr sz="3600" b="1">
-                <a:solidFill>
-                  <a:srgbClr val="666666"/>
-                </a:solidFill>
-                <a:latin typeface="Arial"/>
-              </a:rPr>
-              <a:t>CI/CD PIPELINE</a:t>
-            </a:r>
-          </a:p>
-        </p:txBody>
-      </p:sp>
-      <p:sp>
-        <p:nvSpPr>
-          <p:cNvPr id="90" name="TextBox 89"/>
-          <p:cNvSpPr txBox="1"/>
-          <p:nvPr/>
-        </p:nvSpPr>
-        <p:spPr>
-          <a:xfrm>
-            <a:off x="35753040" y="12847320"/>
-            <a:ext cx="6766560" cy="457200"/>
-          </a:xfrm>
-          <a:prstGeom prst="rect">
-            <a:avLst/>
-          </a:prstGeom>
-          <a:noFill/>
-        </p:spPr>
-        <p:txBody>
-          <a:bodyPr wrap="square"/>
-          <a:lstStyle/>
-          <a:p>
-            <a:pPr algn="ctr"/>
-            <a:r>
-              <a:rPr sz="2200" b="0">
-                <a:solidFill>
-                  <a:srgbClr val="666666"/>
-                </a:solidFill>
-                <a:latin typeface="Arial"/>
-              </a:rPr>
-              <a:t>GitHub Actions</a:t>
-            </a:r>
-          </a:p>
-        </p:txBody>
-      </p:sp>
-      <p:sp>
-        <p:nvSpPr>
-          <p:cNvPr id="91" name="Rectangle 90"/>
+          <p:cNvPr id="93" name="Rectangle 92"/>
           <p:cNvSpPr/>
           <p:nvPr/>
         </p:nvSpPr>
         <p:spPr>
           <a:xfrm>
-            <a:off x="28620720" y="15544800"/>
-            <a:ext cx="182880" cy="640080"/>
+            <a:off x="28620720" y="9418320"/>
+            <a:ext cx="182880" cy="685800"/>
           </a:xfrm>
           <a:prstGeom prst="rect">
             <a:avLst/>
@@ -3678,14 +3815,14 @@
       </p:sp>
       <p:sp>
         <p:nvSpPr>
-          <p:cNvPr id="92" name="TextBox 91"/>
+          <p:cNvPr id="94" name="TextBox 93"/>
           <p:cNvSpPr txBox="1"/>
           <p:nvPr/>
         </p:nvSpPr>
         <p:spPr>
           <a:xfrm>
-            <a:off x="28986480" y="15526512"/>
-            <a:ext cx="13533120" cy="640080"/>
+            <a:off x="28986480" y="9464040"/>
+            <a:ext cx="13441680" cy="594360"/>
           </a:xfrm>
           <a:prstGeom prst="rect">
             <a:avLst/>
@@ -3698,37 +3835,37 @@
           <a:p>
             <a:pPr algn="l"/>
             <a:r>
-              <a:rPr sz="4800" b="1">
+              <a:rPr sz="4400" b="1">
                 <a:solidFill>
                   <a:srgbClr val="FFFFFF"/>
                 </a:solidFill>
                 <a:latin typeface="Arial"/>
               </a:rPr>
-              <a:t>Test Infrastructure</a:t>
-            </a:r>
-          </a:p>
-        </p:txBody>
-      </p:sp>
-      <p:sp>
-        <p:nvSpPr>
-          <p:cNvPr id="93" name="Rounded Rectangle 92"/>
+              <a:t>Task Board &amp; CI/CD</a:t>
+            </a:r>
+          </a:p>
+        </p:txBody>
+      </p:sp>
+      <p:sp>
+        <p:nvSpPr>
+          <p:cNvPr id="95" name="Rounded Rectangle 94"/>
           <p:cNvSpPr/>
           <p:nvPr/>
         </p:nvSpPr>
         <p:spPr>
           <a:xfrm>
-            <a:off x="28620720" y="16322040"/>
-            <a:ext cx="6766560" cy="4572000"/>
+            <a:off x="28620720" y="10241280"/>
+            <a:ext cx="6766560" cy="5029200"/>
           </a:xfrm>
           <a:prstGeom prst="roundRect">
             <a:avLst/>
           </a:prstGeom>
           <a:solidFill>
-            <a:srgbClr val="E8E8E8"/>
+            <a:srgbClr val="ECECEC"/>
           </a:solidFill>
-          <a:ln w="25400">
+          <a:ln w="19050">
             <a:solidFill>
-              <a:srgbClr val="666666"/>
+              <a:srgbClr val="AAAAAA"/>
             </a:solidFill>
             <a:prstDash val="dash"/>
           </a:ln>
@@ -3758,13 +3895,13 @@
       </p:sp>
       <p:sp>
         <p:nvSpPr>
-          <p:cNvPr id="94" name="TextBox 93"/>
+          <p:cNvPr id="96" name="TextBox 95"/>
           <p:cNvSpPr txBox="1"/>
           <p:nvPr/>
         </p:nvSpPr>
         <p:spPr>
           <a:xfrm>
-            <a:off x="28620720" y="18196560"/>
+            <a:off x="28620720" y="12344400"/>
             <a:ext cx="6766560" cy="548640"/>
           </a:xfrm>
           <a:prstGeom prst="rect">
@@ -3780,24 +3917,24 @@
             <a:r>
               <a:rPr sz="3600" b="1">
                 <a:solidFill>
-                  <a:srgbClr val="666666"/>
+                  <a:srgbClr val="AAAAAA"/>
                 </a:solidFill>
                 <a:latin typeface="Arial"/>
               </a:rPr>
-              <a:t>TEST RESULTS</a:t>
-            </a:r>
-          </a:p>
-        </p:txBody>
-      </p:sp>
-      <p:sp>
-        <p:nvSpPr>
-          <p:cNvPr id="95" name="TextBox 94"/>
+              <a:t>TASK BOARD</a:t>
+            </a:r>
+          </a:p>
+        </p:txBody>
+      </p:sp>
+      <p:sp>
+        <p:nvSpPr>
+          <p:cNvPr id="97" name="TextBox 96"/>
           <p:cNvSpPr txBox="1"/>
           <p:nvPr/>
         </p:nvSpPr>
         <p:spPr>
           <a:xfrm>
-            <a:off x="28620720" y="18790920"/>
+            <a:off x="28620720" y="12938760"/>
             <a:ext cx="6766560" cy="457200"/>
           </a:xfrm>
           <a:prstGeom prst="rect">
@@ -3813,35 +3950,35 @@
             <a:r>
               <a:rPr sz="2200" b="0">
                 <a:solidFill>
-                  <a:srgbClr val="666666"/>
+                  <a:srgbClr val="AAAAAA"/>
                 </a:solidFill>
                 <a:latin typeface="Arial"/>
               </a:rPr>
-              <a:t>xUnit + Moq + Coverlet</a:t>
-            </a:r>
-          </a:p>
-        </p:txBody>
-      </p:sp>
-      <p:sp>
-        <p:nvSpPr>
-          <p:cNvPr id="96" name="Rounded Rectangle 95"/>
+              <a:t>GitHub Kanban</a:t>
+            </a:r>
+          </a:p>
+        </p:txBody>
+      </p:sp>
+      <p:sp>
+        <p:nvSpPr>
+          <p:cNvPr id="98" name="Rounded Rectangle 97"/>
           <p:cNvSpPr/>
           <p:nvPr/>
         </p:nvSpPr>
         <p:spPr>
           <a:xfrm>
-            <a:off x="35753040" y="16322040"/>
-            <a:ext cx="6766560" cy="4572000"/>
+            <a:off x="35753040" y="10241280"/>
+            <a:ext cx="6766560" cy="5029200"/>
           </a:xfrm>
           <a:prstGeom prst="roundRect">
             <a:avLst/>
           </a:prstGeom>
           <a:solidFill>
-            <a:srgbClr val="E8E8E8"/>
+            <a:srgbClr val="ECECEC"/>
           </a:solidFill>
-          <a:ln w="25400">
+          <a:ln w="19050">
             <a:solidFill>
-              <a:srgbClr val="666666"/>
+              <a:srgbClr val="AAAAAA"/>
             </a:solidFill>
             <a:prstDash val="dash"/>
           </a:ln>
@@ -3871,13 +4008,13 @@
       </p:sp>
       <p:sp>
         <p:nvSpPr>
-          <p:cNvPr id="97" name="TextBox 96"/>
+          <p:cNvPr id="99" name="TextBox 98"/>
           <p:cNvSpPr txBox="1"/>
           <p:nvPr/>
         </p:nvSpPr>
         <p:spPr>
           <a:xfrm>
-            <a:off x="35753040" y="18196560"/>
+            <a:off x="35753040" y="12344400"/>
             <a:ext cx="6766560" cy="548640"/>
           </a:xfrm>
           <a:prstGeom prst="rect">
@@ -3893,24 +4030,24 @@
             <a:r>
               <a:rPr sz="3600" b="1">
                 <a:solidFill>
-                  <a:srgbClr val="666666"/>
+                  <a:srgbClr val="AAAAAA"/>
                 </a:solidFill>
                 <a:latin typeface="Arial"/>
               </a:rPr>
-              <a:t>BACKTEST TRACKER</a:t>
-            </a:r>
-          </a:p>
-        </p:txBody>
-      </p:sp>
-      <p:sp>
-        <p:nvSpPr>
-          <p:cNvPr id="98" name="TextBox 97"/>
+              <a:t>CI/CD PIPELINE</a:t>
+            </a:r>
+          </a:p>
+        </p:txBody>
+      </p:sp>
+      <p:sp>
+        <p:nvSpPr>
+          <p:cNvPr id="100" name="TextBox 99"/>
           <p:cNvSpPr txBox="1"/>
           <p:nvPr/>
         </p:nvSpPr>
         <p:spPr>
           <a:xfrm>
-            <a:off x="35753040" y="18790920"/>
+            <a:off x="35753040" y="12938760"/>
             <a:ext cx="6766560" cy="457200"/>
           </a:xfrm>
           <a:prstGeom prst="rect">
@@ -3926,25 +4063,69 @@
             <a:r>
               <a:rPr sz="2200" b="0">
                 <a:solidFill>
-                  <a:srgbClr val="666666"/>
+                  <a:srgbClr val="AAAAAA"/>
                 </a:solidFill>
                 <a:latin typeface="Arial"/>
               </a:rPr>
-              <a:t>Strategy validation</a:t>
-            </a:r>
-          </a:p>
-        </p:txBody>
-      </p:sp>
-      <p:sp>
-        <p:nvSpPr>
-          <p:cNvPr id="99" name="Rectangle 98"/>
+              <a:t>GitHub Actions</a:t>
+            </a:r>
+          </a:p>
+        </p:txBody>
+      </p:sp>
+      <p:sp>
+        <p:nvSpPr>
+          <p:cNvPr id="101" name="Rectangle 100"/>
           <p:cNvSpPr/>
           <p:nvPr/>
         </p:nvSpPr>
         <p:spPr>
           <a:xfrm>
-            <a:off x="28620720" y="21259800"/>
-            <a:ext cx="182880" cy="640080"/>
+            <a:off x="28620720" y="15636240"/>
+            <a:ext cx="13898880" cy="685800"/>
+          </a:xfrm>
+          <a:prstGeom prst="rect">
+            <a:avLst/>
+          </a:prstGeom>
+          <a:solidFill>
+            <a:srgbClr val="1A1A1A"/>
+          </a:solidFill>
+          <a:ln>
+            <a:noFill/>
+          </a:ln>
+          <a:effectLst/>
+        </p:spPr>
+        <p:style>
+          <a:lnRef idx="1">
+            <a:schemeClr val="accent1"/>
+          </a:lnRef>
+          <a:fillRef idx="3">
+            <a:schemeClr val="accent1"/>
+          </a:fillRef>
+          <a:effectRef idx="2">
+            <a:schemeClr val="accent1"/>
+          </a:effectRef>
+          <a:fontRef idx="minor">
+            <a:schemeClr val="lt1"/>
+          </a:fontRef>
+        </p:style>
+        <p:txBody>
+          <a:bodyPr rtlCol="0" anchor="ctr"/>
+          <a:lstStyle/>
+          <a:p>
+            <a:pPr algn="ctr"/>
+          </a:p>
+        </p:txBody>
+      </p:sp>
+      <p:sp>
+        <p:nvSpPr>
+          <p:cNvPr id="102" name="Rectangle 101"/>
+          <p:cNvSpPr/>
+          <p:nvPr/>
+        </p:nvSpPr>
+        <p:spPr>
+          <a:xfrm>
+            <a:off x="28620720" y="15636240"/>
+            <a:ext cx="182880" cy="685800"/>
           </a:xfrm>
           <a:prstGeom prst="rect">
             <a:avLst/>
@@ -3981,14 +4162,14 @@
       </p:sp>
       <p:sp>
         <p:nvSpPr>
-          <p:cNvPr id="100" name="TextBox 99"/>
+          <p:cNvPr id="103" name="TextBox 102"/>
           <p:cNvSpPr txBox="1"/>
           <p:nvPr/>
         </p:nvSpPr>
         <p:spPr>
           <a:xfrm>
-            <a:off x="28986480" y="21241512"/>
-            <a:ext cx="13533120" cy="640080"/>
+            <a:off x="28986480" y="15681960"/>
+            <a:ext cx="13441680" cy="594360"/>
           </a:xfrm>
           <a:prstGeom prst="rect">
             <a:avLst/>
@@ -4001,12 +4182,359 @@
           <a:p>
             <a:pPr algn="l"/>
             <a:r>
-              <a:rPr sz="4800" b="1">
+              <a:rPr sz="4400" b="1">
                 <a:solidFill>
                   <a:srgbClr val="FFFFFF"/>
                 </a:solidFill>
                 <a:latin typeface="Arial"/>
               </a:rPr>
+              <a:t>Test Infrastructure</a:t>
+            </a:r>
+          </a:p>
+        </p:txBody>
+      </p:sp>
+      <p:sp>
+        <p:nvSpPr>
+          <p:cNvPr id="104" name="Rounded Rectangle 103"/>
+          <p:cNvSpPr/>
+          <p:nvPr/>
+        </p:nvSpPr>
+        <p:spPr>
+          <a:xfrm>
+            <a:off x="28620720" y="16459200"/>
+            <a:ext cx="6766560" cy="4572000"/>
+          </a:xfrm>
+          <a:prstGeom prst="roundRect">
+            <a:avLst/>
+          </a:prstGeom>
+          <a:solidFill>
+            <a:srgbClr val="ECECEC"/>
+          </a:solidFill>
+          <a:ln w="19050">
+            <a:solidFill>
+              <a:srgbClr val="AAAAAA"/>
+            </a:solidFill>
+            <a:prstDash val="dash"/>
+          </a:ln>
+          <a:effectLst/>
+        </p:spPr>
+        <p:style>
+          <a:lnRef idx="1">
+            <a:schemeClr val="accent1"/>
+          </a:lnRef>
+          <a:fillRef idx="3">
+            <a:schemeClr val="accent1"/>
+          </a:fillRef>
+          <a:effectRef idx="2">
+            <a:schemeClr val="accent1"/>
+          </a:effectRef>
+          <a:fontRef idx="minor">
+            <a:schemeClr val="lt1"/>
+          </a:fontRef>
+        </p:style>
+        <p:txBody>
+          <a:bodyPr rtlCol="0" anchor="ctr"/>
+          <a:lstStyle/>
+          <a:p>
+            <a:pPr algn="ctr"/>
+          </a:p>
+        </p:txBody>
+      </p:sp>
+      <p:sp>
+        <p:nvSpPr>
+          <p:cNvPr id="105" name="TextBox 104"/>
+          <p:cNvSpPr txBox="1"/>
+          <p:nvPr/>
+        </p:nvSpPr>
+        <p:spPr>
+          <a:xfrm>
+            <a:off x="28620720" y="18333720"/>
+            <a:ext cx="6766560" cy="548640"/>
+          </a:xfrm>
+          <a:prstGeom prst="rect">
+            <a:avLst/>
+          </a:prstGeom>
+          <a:noFill/>
+        </p:spPr>
+        <p:txBody>
+          <a:bodyPr wrap="square"/>
+          <a:lstStyle/>
+          <a:p>
+            <a:pPr algn="ctr"/>
+            <a:r>
+              <a:rPr sz="3600" b="1">
+                <a:solidFill>
+                  <a:srgbClr val="AAAAAA"/>
+                </a:solidFill>
+                <a:latin typeface="Arial"/>
+              </a:rPr>
+              <a:t>TEST RESULTS</a:t>
+            </a:r>
+          </a:p>
+        </p:txBody>
+      </p:sp>
+      <p:sp>
+        <p:nvSpPr>
+          <p:cNvPr id="106" name="TextBox 105"/>
+          <p:cNvSpPr txBox="1"/>
+          <p:nvPr/>
+        </p:nvSpPr>
+        <p:spPr>
+          <a:xfrm>
+            <a:off x="28620720" y="18928080"/>
+            <a:ext cx="6766560" cy="457200"/>
+          </a:xfrm>
+          <a:prstGeom prst="rect">
+            <a:avLst/>
+          </a:prstGeom>
+          <a:noFill/>
+        </p:spPr>
+        <p:txBody>
+          <a:bodyPr wrap="square"/>
+          <a:lstStyle/>
+          <a:p>
+            <a:pPr algn="ctr"/>
+            <a:r>
+              <a:rPr sz="2200" b="0">
+                <a:solidFill>
+                  <a:srgbClr val="AAAAAA"/>
+                </a:solidFill>
+                <a:latin typeface="Arial"/>
+              </a:rPr>
+              <a:t>xUnit + Moq + Coverlet</a:t>
+            </a:r>
+          </a:p>
+        </p:txBody>
+      </p:sp>
+      <p:sp>
+        <p:nvSpPr>
+          <p:cNvPr id="107" name="Rounded Rectangle 106"/>
+          <p:cNvSpPr/>
+          <p:nvPr/>
+        </p:nvSpPr>
+        <p:spPr>
+          <a:xfrm>
+            <a:off x="35753040" y="16459200"/>
+            <a:ext cx="6766560" cy="4572000"/>
+          </a:xfrm>
+          <a:prstGeom prst="roundRect">
+            <a:avLst/>
+          </a:prstGeom>
+          <a:solidFill>
+            <a:srgbClr val="ECECEC"/>
+          </a:solidFill>
+          <a:ln w="19050">
+            <a:solidFill>
+              <a:srgbClr val="AAAAAA"/>
+            </a:solidFill>
+            <a:prstDash val="dash"/>
+          </a:ln>
+          <a:effectLst/>
+        </p:spPr>
+        <p:style>
+          <a:lnRef idx="1">
+            <a:schemeClr val="accent1"/>
+          </a:lnRef>
+          <a:fillRef idx="3">
+            <a:schemeClr val="accent1"/>
+          </a:fillRef>
+          <a:effectRef idx="2">
+            <a:schemeClr val="accent1"/>
+          </a:effectRef>
+          <a:fontRef idx="minor">
+            <a:schemeClr val="lt1"/>
+          </a:fontRef>
+        </p:style>
+        <p:txBody>
+          <a:bodyPr rtlCol="0" anchor="ctr"/>
+          <a:lstStyle/>
+          <a:p>
+            <a:pPr algn="ctr"/>
+          </a:p>
+        </p:txBody>
+      </p:sp>
+      <p:sp>
+        <p:nvSpPr>
+          <p:cNvPr id="108" name="TextBox 107"/>
+          <p:cNvSpPr txBox="1"/>
+          <p:nvPr/>
+        </p:nvSpPr>
+        <p:spPr>
+          <a:xfrm>
+            <a:off x="35753040" y="18333720"/>
+            <a:ext cx="6766560" cy="548640"/>
+          </a:xfrm>
+          <a:prstGeom prst="rect">
+            <a:avLst/>
+          </a:prstGeom>
+          <a:noFill/>
+        </p:spPr>
+        <p:txBody>
+          <a:bodyPr wrap="square"/>
+          <a:lstStyle/>
+          <a:p>
+            <a:pPr algn="ctr"/>
+            <a:r>
+              <a:rPr sz="3600" b="1">
+                <a:solidFill>
+                  <a:srgbClr val="AAAAAA"/>
+                </a:solidFill>
+                <a:latin typeface="Arial"/>
+              </a:rPr>
+              <a:t>BACKTEST TRACKER</a:t>
+            </a:r>
+          </a:p>
+        </p:txBody>
+      </p:sp>
+      <p:sp>
+        <p:nvSpPr>
+          <p:cNvPr id="109" name="TextBox 108"/>
+          <p:cNvSpPr txBox="1"/>
+          <p:nvPr/>
+        </p:nvSpPr>
+        <p:spPr>
+          <a:xfrm>
+            <a:off x="35753040" y="18928080"/>
+            <a:ext cx="6766560" cy="457200"/>
+          </a:xfrm>
+          <a:prstGeom prst="rect">
+            <a:avLst/>
+          </a:prstGeom>
+          <a:noFill/>
+        </p:spPr>
+        <p:txBody>
+          <a:bodyPr wrap="square"/>
+          <a:lstStyle/>
+          <a:p>
+            <a:pPr algn="ctr"/>
+            <a:r>
+              <a:rPr sz="2200" b="0">
+                <a:solidFill>
+                  <a:srgbClr val="AAAAAA"/>
+                </a:solidFill>
+                <a:latin typeface="Arial"/>
+              </a:rPr>
+              <a:t>Strategy validation</a:t>
+            </a:r>
+          </a:p>
+        </p:txBody>
+      </p:sp>
+      <p:sp>
+        <p:nvSpPr>
+          <p:cNvPr id="110" name="Rectangle 109"/>
+          <p:cNvSpPr/>
+          <p:nvPr/>
+        </p:nvSpPr>
+        <p:spPr>
+          <a:xfrm>
+            <a:off x="28620720" y="21396960"/>
+            <a:ext cx="13898880" cy="685800"/>
+          </a:xfrm>
+          <a:prstGeom prst="rect">
+            <a:avLst/>
+          </a:prstGeom>
+          <a:solidFill>
+            <a:srgbClr val="1A1A1A"/>
+          </a:solidFill>
+          <a:ln>
+            <a:noFill/>
+          </a:ln>
+          <a:effectLst/>
+        </p:spPr>
+        <p:style>
+          <a:lnRef idx="1">
+            <a:schemeClr val="accent1"/>
+          </a:lnRef>
+          <a:fillRef idx="3">
+            <a:schemeClr val="accent1"/>
+          </a:fillRef>
+          <a:effectRef idx="2">
+            <a:schemeClr val="accent1"/>
+          </a:effectRef>
+          <a:fontRef idx="minor">
+            <a:schemeClr val="lt1"/>
+          </a:fontRef>
+        </p:style>
+        <p:txBody>
+          <a:bodyPr rtlCol="0" anchor="ctr"/>
+          <a:lstStyle/>
+          <a:p>
+            <a:pPr algn="ctr"/>
+          </a:p>
+        </p:txBody>
+      </p:sp>
+      <p:sp>
+        <p:nvSpPr>
+          <p:cNvPr id="111" name="Rectangle 110"/>
+          <p:cNvSpPr/>
+          <p:nvPr/>
+        </p:nvSpPr>
+        <p:spPr>
+          <a:xfrm>
+            <a:off x="28620720" y="21396960"/>
+            <a:ext cx="182880" cy="685800"/>
+          </a:xfrm>
+          <a:prstGeom prst="rect">
+            <a:avLst/>
+          </a:prstGeom>
+          <a:solidFill>
+            <a:srgbClr val="FFC000"/>
+          </a:solidFill>
+          <a:ln>
+            <a:noFill/>
+          </a:ln>
+          <a:effectLst/>
+        </p:spPr>
+        <p:style>
+          <a:lnRef idx="1">
+            <a:schemeClr val="accent1"/>
+          </a:lnRef>
+          <a:fillRef idx="3">
+            <a:schemeClr val="accent1"/>
+          </a:fillRef>
+          <a:effectRef idx="2">
+            <a:schemeClr val="accent1"/>
+          </a:effectRef>
+          <a:fontRef idx="minor">
+            <a:schemeClr val="lt1"/>
+          </a:fontRef>
+        </p:style>
+        <p:txBody>
+          <a:bodyPr rtlCol="0" anchor="ctr"/>
+          <a:lstStyle/>
+          <a:p>
+            <a:pPr algn="ctr"/>
+          </a:p>
+        </p:txBody>
+      </p:sp>
+      <p:sp>
+        <p:nvSpPr>
+          <p:cNvPr id="112" name="TextBox 111"/>
+          <p:cNvSpPr txBox="1"/>
+          <p:nvPr/>
+        </p:nvSpPr>
+        <p:spPr>
+          <a:xfrm>
+            <a:off x="28986480" y="21442680"/>
+            <a:ext cx="13441680" cy="594360"/>
+          </a:xfrm>
+          <a:prstGeom prst="rect">
+            <a:avLst/>
+          </a:prstGeom>
+          <a:noFill/>
+        </p:spPr>
+        <p:txBody>
+          <a:bodyPr wrap="square"/>
+          <a:lstStyle/>
+          <a:p>
+            <a:pPr algn="l"/>
+            <a:r>
+              <a:rPr sz="4400" b="1">
+                <a:solidFill>
+                  <a:srgbClr val="FFFFFF"/>
+                </a:solidFill>
+                <a:latin typeface="Arial"/>
+              </a:rPr>
               <a:t>Key Engineering Decisions</a:t>
             </a:r>
           </a:p>
@@ -4014,13 +4542,13 @@
       </p:sp>
       <p:sp>
         <p:nvSpPr>
-          <p:cNvPr id="101" name="TextBox 100"/>
+          <p:cNvPr id="113" name="TextBox 112"/>
           <p:cNvSpPr txBox="1"/>
           <p:nvPr/>
         </p:nvSpPr>
         <p:spPr>
           <a:xfrm>
-            <a:off x="28803600" y="22037040"/>
+            <a:off x="28803600" y="22219920"/>
             <a:ext cx="13533120" cy="2834640"/>
           </a:xfrm>
           <a:prstGeom prst="rect">
@@ -4042,7 +4570,7 @@
             <a:r>
               <a:rPr sz="3000">
                 <a:solidFill>
-                  <a:srgbClr val="FFFFFF"/>
+                  <a:srgbClr val="2D2D2D"/>
                 </a:solidFill>
                 <a:latin typeface="Arial"/>
               </a:rPr>
@@ -4058,7 +4586,7 @@
             <a:r>
               <a:rPr sz="3000">
                 <a:solidFill>
-                  <a:srgbClr val="FFFFFF"/>
+                  <a:srgbClr val="2D2D2D"/>
                 </a:solidFill>
                 <a:latin typeface="Arial"/>
               </a:rPr>
@@ -4074,7 +4602,7 @@
             <a:r>
               <a:rPr sz="3000">
                 <a:solidFill>
-                  <a:srgbClr val="FFFFFF"/>
+                  <a:srgbClr val="2D2D2D"/>
                 </a:solidFill>
                 <a:latin typeface="Arial"/>
               </a:rPr>
@@ -4090,7 +4618,7 @@
             <a:r>
               <a:rPr sz="3000">
                 <a:solidFill>
-                  <a:srgbClr val="FFFFFF"/>
+                  <a:srgbClr val="2D2D2D"/>
                 </a:solidFill>
                 <a:latin typeface="Arial"/>
               </a:rPr>
@@ -4106,7 +4634,7 @@
             <a:r>
               <a:rPr sz="3000">
                 <a:solidFill>
-                  <a:srgbClr val="FFFFFF"/>
+                  <a:srgbClr val="2D2D2D"/>
                 </a:solidFill>
                 <a:latin typeface="Arial"/>
               </a:rPr>
@@ -4117,7 +4645,7 @@
       </p:sp>
       <p:sp>
         <p:nvSpPr>
-          <p:cNvPr id="102" name="Rounded Rectangle 101"/>
+          <p:cNvPr id="114" name="Rounded Rectangle 113"/>
           <p:cNvSpPr/>
           <p:nvPr/>
         </p:nvSpPr>
@@ -4130,11 +4658,11 @@
             <a:avLst/>
           </a:prstGeom>
           <a:solidFill>
-            <a:srgbClr val="E8E8E8"/>
+            <a:srgbClr val="ECECEC"/>
           </a:solidFill>
-          <a:ln w="25400">
+          <a:ln w="19050">
             <a:solidFill>
-              <a:srgbClr val="666666"/>
+              <a:srgbClr val="AAAAAA"/>
             </a:solidFill>
             <a:prstDash val="dash"/>
           </a:ln>
@@ -4164,7 +4692,7 @@
       </p:sp>
       <p:sp>
         <p:nvSpPr>
-          <p:cNvPr id="103" name="TextBox 102"/>
+          <p:cNvPr id="115" name="TextBox 114"/>
           <p:cNvSpPr txBox="1"/>
           <p:nvPr/>
         </p:nvSpPr>
@@ -4186,7 +4714,7 @@
             <a:r>
               <a:rPr sz="3600" b="1">
                 <a:solidFill>
-                  <a:srgbClr val="666666"/>
+                  <a:srgbClr val="AAAAAA"/>
                 </a:solidFill>
                 <a:latin typeface="Arial"/>
               </a:rPr>
@@ -4197,7 +4725,7 @@
       </p:sp>
       <p:sp>
         <p:nvSpPr>
-          <p:cNvPr id="104" name="TextBox 103"/>
+          <p:cNvPr id="116" name="TextBox 115"/>
           <p:cNvSpPr txBox="1"/>
           <p:nvPr/>
         </p:nvSpPr>
@@ -4219,7 +4747,7 @@
             <a:r>
               <a:rPr sz="2200" b="0">
                 <a:solidFill>
-                  <a:srgbClr val="666666"/>
+                  <a:srgbClr val="AAAAAA"/>
                 </a:solidFill>
                 <a:latin typeface="Arial"/>
               </a:rPr>

</xml_diff>